<commit_message>
Updates from 2026-09-24 - definition of data science, some screenshots from YouTube videos, formatting slide master
</commit_message>
<xml_diff>
--- a/capstone-project-and-presentation/presentation.pptx
+++ b/capstone-project-and-presentation/presentation.pptx
@@ -7,6 +7,8 @@
   <p:sldIdLst>
     <p:sldId id="256" r:id="rId2"/>
     <p:sldId id="257" r:id="rId3"/>
+    <p:sldId id="258" r:id="rId4"/>
+    <p:sldId id="259" r:id="rId5"/>
   </p:sldIdLst>
   <p:sldSz cx="12192000" cy="6858000"/>
   <p:notesSz cx="6858000" cy="9144000"/>
@@ -105,6 +107,11 @@
       </a:defRPr>
     </a:lvl9pPr>
   </p:defaultTextStyle>
+  <p:extLst>
+    <p:ext uri="{EFAFB233-063F-42B5-8137-9DF3F51BA10A}">
+      <p15:sldGuideLst xmlns:p15="http://schemas.microsoft.com/office/powerpoint/2012/main"/>
+    </p:ext>
+  </p:extLst>
 </p:presentation>
 </file>
 
@@ -257,7 +264,7 @@
           <a:p>
             <a:fld id="{5A937D34-EDB1-4CA3-90B4-747AD5C0EF94}" type="datetimeFigureOut">
               <a:rPr lang="pt-BR" smtClean="0"/>
-              <a:t>23/09/2026</a:t>
+              <a:t>24/09/2026</a:t>
             </a:fld>
             <a:endParaRPr lang="pt-BR"/>
           </a:p>
@@ -457,7 +464,7 @@
           <a:p>
             <a:fld id="{5A937D34-EDB1-4CA3-90B4-747AD5C0EF94}" type="datetimeFigureOut">
               <a:rPr lang="pt-BR" smtClean="0"/>
-              <a:t>23/09/2026</a:t>
+              <a:t>24/09/2026</a:t>
             </a:fld>
             <a:endParaRPr lang="pt-BR"/>
           </a:p>
@@ -667,7 +674,7 @@
           <a:p>
             <a:fld id="{5A937D34-EDB1-4CA3-90B4-747AD5C0EF94}" type="datetimeFigureOut">
               <a:rPr lang="pt-BR" smtClean="0"/>
-              <a:t>23/09/2026</a:t>
+              <a:t>24/09/2026</a:t>
             </a:fld>
             <a:endParaRPr lang="pt-BR"/>
           </a:p>
@@ -872,7 +879,7 @@
           <a:p>
             <a:fld id="{5A937D34-EDB1-4CA3-90B4-747AD5C0EF94}" type="datetimeFigureOut">
               <a:rPr lang="pt-BR" smtClean="0"/>
-              <a:t>23/09/2026</a:t>
+              <a:t>24/09/2026</a:t>
             </a:fld>
             <a:endParaRPr lang="pt-BR"/>
           </a:p>
@@ -1148,7 +1155,7 @@
           <a:p>
             <a:fld id="{5A937D34-EDB1-4CA3-90B4-747AD5C0EF94}" type="datetimeFigureOut">
               <a:rPr lang="pt-BR" smtClean="0"/>
-              <a:t>23/09/2026</a:t>
+              <a:t>24/09/2026</a:t>
             </a:fld>
             <a:endParaRPr lang="pt-BR"/>
           </a:p>
@@ -1416,7 +1423,7 @@
           <a:p>
             <a:fld id="{5A937D34-EDB1-4CA3-90B4-747AD5C0EF94}" type="datetimeFigureOut">
               <a:rPr lang="pt-BR" smtClean="0"/>
-              <a:t>23/09/2026</a:t>
+              <a:t>24/09/2026</a:t>
             </a:fld>
             <a:endParaRPr lang="pt-BR"/>
           </a:p>
@@ -1831,7 +1838,7 @@
           <a:p>
             <a:fld id="{5A937D34-EDB1-4CA3-90B4-747AD5C0EF94}" type="datetimeFigureOut">
               <a:rPr lang="pt-BR" smtClean="0"/>
-              <a:t>23/09/2026</a:t>
+              <a:t>24/09/2026</a:t>
             </a:fld>
             <a:endParaRPr lang="pt-BR"/>
           </a:p>
@@ -1973,7 +1980,7 @@
           <a:p>
             <a:fld id="{5A937D34-EDB1-4CA3-90B4-747AD5C0EF94}" type="datetimeFigureOut">
               <a:rPr lang="pt-BR" smtClean="0"/>
-              <a:t>23/09/2026</a:t>
+              <a:t>24/09/2026</a:t>
             </a:fld>
             <a:endParaRPr lang="pt-BR"/>
           </a:p>
@@ -2086,7 +2093,7 @@
           <a:p>
             <a:fld id="{5A937D34-EDB1-4CA3-90B4-747AD5C0EF94}" type="datetimeFigureOut">
               <a:rPr lang="pt-BR" smtClean="0"/>
-              <a:t>23/09/2026</a:t>
+              <a:t>24/09/2026</a:t>
             </a:fld>
             <a:endParaRPr lang="pt-BR"/>
           </a:p>
@@ -2399,7 +2406,7 @@
           <a:p>
             <a:fld id="{5A937D34-EDB1-4CA3-90B4-747AD5C0EF94}" type="datetimeFigureOut">
               <a:rPr lang="pt-BR" smtClean="0"/>
-              <a:t>23/09/2026</a:t>
+              <a:t>24/09/2026</a:t>
             </a:fld>
             <a:endParaRPr lang="pt-BR"/>
           </a:p>
@@ -2688,7 +2695,7 @@
           <a:p>
             <a:fld id="{5A937D34-EDB1-4CA3-90B4-747AD5C0EF94}" type="datetimeFigureOut">
               <a:rPr lang="pt-BR" smtClean="0"/>
-              <a:t>23/09/2026</a:t>
+              <a:t>24/09/2026</a:t>
             </a:fld>
             <a:endParaRPr lang="pt-BR"/>
           </a:p>
@@ -2931,7 +2938,7 @@
           <a:p>
             <a:fld id="{5A937D34-EDB1-4CA3-90B4-747AD5C0EF94}" type="datetimeFigureOut">
               <a:rPr lang="pt-BR" smtClean="0"/>
-              <a:t>23/09/2026</a:t>
+              <a:t>24/09/2026</a:t>
             </a:fld>
             <a:endParaRPr lang="pt-BR"/>
           </a:p>
@@ -3041,8 +3048,8 @@
         </p:nvSpPr>
         <p:spPr>
           <a:xfrm>
-            <a:off x="423863" y="5955396"/>
-            <a:ext cx="11344275" cy="738664"/>
+            <a:off x="828964" y="6269427"/>
+            <a:ext cx="10515600" cy="553998"/>
           </a:xfrm>
           <a:prstGeom prst="rect">
             <a:avLst/>
@@ -3056,34 +3063,34 @@
           <a:lstStyle/>
           <a:p>
             <a:r>
-              <a:rPr lang="en-US" sz="1400" dirty="0"/>
+              <a:rPr lang="en-US" sz="1000" dirty="0"/>
               <a:t>Based on course “</a:t>
             </a:r>
             <a:r>
-              <a:rPr lang="pt-BR" sz="1400" b="1" dirty="0"/>
+              <a:rPr lang="pt-BR" sz="1000" b="1" dirty="0"/>
               <a:t>Fundamentos de Aprendizado de Máquina e Ciência de Dados para Inteligência Artificial”</a:t>
             </a:r>
             <a:r>
-              <a:rPr lang="en-US" sz="1400" dirty="0"/>
+              <a:rPr lang="en-US" sz="1000" dirty="0"/>
               <a:t> taught by Professor Francisco Rodrigues (ICMC-USP) between August and September 2026</a:t>
             </a:r>
           </a:p>
           <a:p>
             <a:r>
-              <a:rPr lang="en-US" sz="1400" dirty="0"/>
+              <a:rPr lang="en-US" sz="1000" dirty="0"/>
               <a:t>Website: </a:t>
             </a:r>
             <a:r>
-              <a:rPr lang="pt-BR" sz="1400" dirty="0">
+              <a:rPr lang="pt-BR" sz="1000" dirty="0">
                 <a:hlinkClick r:id="rId13"/>
               </a:rPr>
               <a:t>https://sites.icmc.usp.br/francisco/index.html</a:t>
             </a:r>
             <a:r>
-              <a:rPr lang="pt-BR" sz="1400" dirty="0"/>
+              <a:rPr lang="pt-BR" sz="1000" dirty="0"/>
               <a:t> </a:t>
             </a:r>
-            <a:endParaRPr lang="en-US" sz="1400" dirty="0"/>
+            <a:endParaRPr lang="en-US" sz="1000" dirty="0"/>
           </a:p>
         </p:txBody>
       </p:sp>
@@ -3964,10 +3971,333 @@
           </a:p>
         </p:txBody>
       </p:sp>
+      <p:sp>
+        <p:nvSpPr>
+          <p:cNvPr id="5" name="TextBox 4">
+            <a:extLst>
+              <a:ext uri="{FF2B5EF4-FFF2-40B4-BE49-F238E27FC236}">
+                <a16:creationId xmlns:a16="http://schemas.microsoft.com/office/drawing/2014/main" id="{7ACA5A73-239A-F8BB-340C-3FC273412101}"/>
+              </a:ext>
+            </a:extLst>
+          </p:cNvPr>
+          <p:cNvSpPr txBox="1"/>
+          <p:nvPr/>
+        </p:nvSpPr>
+        <p:spPr>
+          <a:xfrm>
+            <a:off x="543300" y="1449303"/>
+            <a:ext cx="5552700" cy="4359142"/>
+          </a:xfrm>
+          <a:prstGeom prst="rect">
+            <a:avLst/>
+          </a:prstGeom>
+          <a:noFill/>
+        </p:spPr>
+        <p:txBody>
+          <a:bodyPr wrap="square">
+            <a:spAutoFit/>
+          </a:bodyPr>
+          <a:lstStyle/>
+          <a:p>
+            <a:pPr>
+              <a:lnSpc>
+                <a:spcPct val="150000"/>
+              </a:lnSpc>
+            </a:pPr>
+            <a:r>
+              <a:rPr lang="en-US" noProof="0" dirty="0"/>
+              <a:t>Data science is an </a:t>
+            </a:r>
+            <a:r>
+              <a:rPr lang="en-US" b="1" noProof="0" dirty="0">
+                <a:solidFill>
+                  <a:schemeClr val="accent6"/>
+                </a:solidFill>
+              </a:rPr>
+              <a:t>interdisciplinary academic field </a:t>
+            </a:r>
+            <a:r>
+              <a:rPr lang="en-US" noProof="0" dirty="0"/>
+              <a:t>that uses statistics, scientific computing, scientific methods, processing, scientific visualization, algorithms, coding (like Python, SQL, and R), and </a:t>
+            </a:r>
+            <a:r>
+              <a:rPr lang="en-US" b="1" noProof="0" dirty="0">
+                <a:solidFill>
+                  <a:schemeClr val="accent6"/>
+                </a:solidFill>
+              </a:rPr>
+              <a:t>systems to extract or extrapolate knowledge </a:t>
+            </a:r>
+            <a:r>
+              <a:rPr lang="en-US" noProof="0" dirty="0"/>
+              <a:t>from potentially noisy, structured, or unstructured data. A data scientist is a </a:t>
+            </a:r>
+            <a:r>
+              <a:rPr lang="en-US" b="1" noProof="0" dirty="0">
+                <a:solidFill>
+                  <a:schemeClr val="accent6"/>
+                </a:solidFill>
+              </a:rPr>
+              <a:t>professional who creates programming code and combines it with statistical knowledge to summarize data</a:t>
+            </a:r>
+            <a:r>
+              <a:rPr lang="en-US" noProof="0" dirty="0"/>
+              <a:t>.</a:t>
+            </a:r>
+          </a:p>
+          <a:p>
+            <a:pPr>
+              <a:lnSpc>
+                <a:spcPct val="150000"/>
+              </a:lnSpc>
+            </a:pPr>
+            <a:r>
+              <a:rPr lang="en-US" sz="1200" i="1" dirty="0"/>
+              <a:t>Source: </a:t>
+            </a:r>
+            <a:r>
+              <a:rPr lang="en-US" sz="1200" i="1" dirty="0">
+                <a:hlinkClick r:id="rId2"/>
+              </a:rPr>
+              <a:t>https://en.wikipedia.org/wiki/Data_science</a:t>
+            </a:r>
+            <a:r>
+              <a:rPr lang="en-US" sz="1200" i="1" dirty="0"/>
+              <a:t>. Accessed in September 24, 2026</a:t>
+            </a:r>
+            <a:endParaRPr lang="en-US" sz="1200" i="1" noProof="0" dirty="0"/>
+          </a:p>
+        </p:txBody>
+      </p:sp>
     </p:spTree>
     <p:extLst>
       <p:ext uri="{BB962C8B-B14F-4D97-AF65-F5344CB8AC3E}">
         <p14:creationId xmlns:p14="http://schemas.microsoft.com/office/powerpoint/2010/main" val="3773299908"/>
+      </p:ext>
+    </p:extLst>
+  </p:cSld>
+  <p:clrMapOvr>
+    <a:masterClrMapping/>
+  </p:clrMapOvr>
+</p:sld>
+</file>
+
+<file path=ppt/slides/slide3.xml><?xml version="1.0" encoding="utf-8"?>
+<p:sld xmlns:a="http://schemas.openxmlformats.org/drawingml/2006/main" xmlns:r="http://schemas.openxmlformats.org/officeDocument/2006/relationships" xmlns:p="http://schemas.openxmlformats.org/presentationml/2006/main">
+  <p:cSld>
+    <p:spTree>
+      <p:nvGrpSpPr>
+        <p:cNvPr id="1" name=""/>
+        <p:cNvGrpSpPr/>
+        <p:nvPr/>
+      </p:nvGrpSpPr>
+      <p:grpSpPr>
+        <a:xfrm>
+          <a:off x="0" y="0"/>
+          <a:ext cx="0" cy="0"/>
+          <a:chOff x="0" y="0"/>
+          <a:chExt cx="0" cy="0"/>
+        </a:xfrm>
+      </p:grpSpPr>
+      <p:pic>
+        <p:nvPicPr>
+          <p:cNvPr id="5" name="Picture 4">
+            <a:extLst>
+              <a:ext uri="{FF2B5EF4-FFF2-40B4-BE49-F238E27FC236}">
+                <a16:creationId xmlns:a16="http://schemas.microsoft.com/office/drawing/2014/main" id="{B8B5A95D-60AC-B09B-AF33-F13DC6600AB8}"/>
+              </a:ext>
+            </a:extLst>
+          </p:cNvPr>
+          <p:cNvPicPr>
+            <a:picLocks noChangeAspect="1"/>
+          </p:cNvPicPr>
+          <p:nvPr/>
+        </p:nvPicPr>
+        <p:blipFill>
+          <a:blip r:embed="rId2"/>
+          <a:stretch>
+            <a:fillRect/>
+          </a:stretch>
+        </p:blipFill>
+        <p:spPr>
+          <a:xfrm>
+            <a:off x="3285733" y="709095"/>
+            <a:ext cx="5620534" cy="4505954"/>
+          </a:xfrm>
+          <a:prstGeom prst="rect">
+            <a:avLst/>
+          </a:prstGeom>
+        </p:spPr>
+      </p:pic>
+      <p:sp>
+        <p:nvSpPr>
+          <p:cNvPr id="7" name="TextBox 6">
+            <a:extLst>
+              <a:ext uri="{FF2B5EF4-FFF2-40B4-BE49-F238E27FC236}">
+                <a16:creationId xmlns:a16="http://schemas.microsoft.com/office/drawing/2014/main" id="{BFBBD93D-BE5A-9E4B-175E-4EC540B1361E}"/>
+              </a:ext>
+            </a:extLst>
+          </p:cNvPr>
+          <p:cNvSpPr txBox="1"/>
+          <p:nvPr/>
+        </p:nvSpPr>
+        <p:spPr>
+          <a:xfrm>
+            <a:off x="3285733" y="5306110"/>
+            <a:ext cx="5515367" cy="276999"/>
+          </a:xfrm>
+          <a:prstGeom prst="rect">
+            <a:avLst/>
+          </a:prstGeom>
+          <a:noFill/>
+        </p:spPr>
+        <p:txBody>
+          <a:bodyPr wrap="square">
+            <a:spAutoFit/>
+          </a:bodyPr>
+          <a:lstStyle/>
+          <a:p>
+            <a:pPr algn="ctr"/>
+            <a:r>
+              <a:rPr lang="pt-BR" sz="1200" i="1" dirty="0">
+                <a:hlinkClick r:id="rId3"/>
+              </a:rPr>
+              <a:t>https://x.com/kareem_carr/status/1375454483061338113</a:t>
+            </a:r>
+            <a:endParaRPr lang="en-US" sz="1200" i="1" dirty="0"/>
+          </a:p>
+        </p:txBody>
+      </p:sp>
+    </p:spTree>
+    <p:extLst>
+      <p:ext uri="{BB962C8B-B14F-4D97-AF65-F5344CB8AC3E}">
+        <p14:creationId xmlns:p14="http://schemas.microsoft.com/office/powerpoint/2010/main" val="1562214499"/>
+      </p:ext>
+    </p:extLst>
+  </p:cSld>
+  <p:clrMapOvr>
+    <a:masterClrMapping/>
+  </p:clrMapOvr>
+</p:sld>
+</file>
+
+<file path=ppt/slides/slide4.xml><?xml version="1.0" encoding="utf-8"?>
+<p:sld xmlns:a="http://schemas.openxmlformats.org/drawingml/2006/main" xmlns:r="http://schemas.openxmlformats.org/officeDocument/2006/relationships" xmlns:p="http://schemas.openxmlformats.org/presentationml/2006/main">
+  <p:cSld>
+    <p:spTree>
+      <p:nvGrpSpPr>
+        <p:cNvPr id="1" name=""/>
+        <p:cNvGrpSpPr/>
+        <p:nvPr/>
+      </p:nvGrpSpPr>
+      <p:grpSpPr>
+        <a:xfrm>
+          <a:off x="0" y="0"/>
+          <a:ext cx="0" cy="0"/>
+          <a:chOff x="0" y="0"/>
+          <a:chExt cx="0" cy="0"/>
+        </a:xfrm>
+      </p:grpSpPr>
+      <p:sp>
+        <p:nvSpPr>
+          <p:cNvPr id="2" name="Title 1">
+            <a:extLst>
+              <a:ext uri="{FF2B5EF4-FFF2-40B4-BE49-F238E27FC236}">
+                <a16:creationId xmlns:a16="http://schemas.microsoft.com/office/drawing/2014/main" id="{A207CCD8-085E-891B-C4EF-524A1E9523A2}"/>
+              </a:ext>
+            </a:extLst>
+          </p:cNvPr>
+          <p:cNvSpPr>
+            <a:spLocks noGrp="1"/>
+          </p:cNvSpPr>
+          <p:nvPr>
+            <p:ph type="title"/>
+          </p:nvPr>
+        </p:nvSpPr>
+        <p:spPr/>
+        <p:txBody>
+          <a:bodyPr/>
+          <a:lstStyle/>
+          <a:p>
+            <a:r>
+              <a:rPr lang="en-US" dirty="0"/>
+              <a:t>The science part…</a:t>
+            </a:r>
+          </a:p>
+        </p:txBody>
+      </p:sp>
+      <p:pic>
+        <p:nvPicPr>
+          <p:cNvPr id="5" name="Content Placeholder 4">
+            <a:extLst>
+              <a:ext uri="{FF2B5EF4-FFF2-40B4-BE49-F238E27FC236}">
+                <a16:creationId xmlns:a16="http://schemas.microsoft.com/office/drawing/2014/main" id="{235C8BFE-E618-EF72-0ED5-13B128918509}"/>
+              </a:ext>
+            </a:extLst>
+          </p:cNvPr>
+          <p:cNvPicPr>
+            <a:picLocks noGrp="1" noChangeAspect="1"/>
+          </p:cNvPicPr>
+          <p:nvPr>
+            <p:ph idx="1"/>
+          </p:nvPr>
+        </p:nvPicPr>
+        <p:blipFill>
+          <a:blip r:embed="rId2"/>
+          <a:stretch>
+            <a:fillRect/>
+          </a:stretch>
+        </p:blipFill>
+        <p:spPr>
+          <a:xfrm>
+            <a:off x="2507544" y="1525317"/>
+            <a:ext cx="7176912" cy="4037013"/>
+          </a:xfrm>
+          <a:prstGeom prst="rect">
+            <a:avLst/>
+          </a:prstGeom>
+        </p:spPr>
+      </p:pic>
+      <p:sp>
+        <p:nvSpPr>
+          <p:cNvPr id="7" name="TextBox 6">
+            <a:extLst>
+              <a:ext uri="{FF2B5EF4-FFF2-40B4-BE49-F238E27FC236}">
+                <a16:creationId xmlns:a16="http://schemas.microsoft.com/office/drawing/2014/main" id="{BBA6C836-0766-6002-D104-37A78A46A518}"/>
+              </a:ext>
+            </a:extLst>
+          </p:cNvPr>
+          <p:cNvSpPr txBox="1"/>
+          <p:nvPr/>
+        </p:nvSpPr>
+        <p:spPr>
+          <a:xfrm>
+            <a:off x="2942414" y="5629005"/>
+            <a:ext cx="6094378" cy="276999"/>
+          </a:xfrm>
+          <a:prstGeom prst="rect">
+            <a:avLst/>
+          </a:prstGeom>
+          <a:noFill/>
+        </p:spPr>
+        <p:txBody>
+          <a:bodyPr wrap="square">
+            <a:spAutoFit/>
+          </a:bodyPr>
+          <a:lstStyle/>
+          <a:p>
+            <a:pPr algn="ctr"/>
+            <a:r>
+              <a:rPr lang="en-US" sz="1200" i="1" dirty="0"/>
+              <a:t>https://youtu.be/5cPzNmtoZDU?si=Fz8N8r1vKzHCrENF&amp;t=15</a:t>
+            </a:r>
+          </a:p>
+        </p:txBody>
+      </p:sp>
+    </p:spTree>
+    <p:extLst>
+      <p:ext uri="{BB962C8B-B14F-4D97-AF65-F5344CB8AC3E}">
+        <p14:creationId xmlns:p14="http://schemas.microsoft.com/office/powerpoint/2010/main" val="3662825304"/>
       </p:ext>
     </p:extLst>
   </p:cSld>

</xml_diff>